<commit_message>
Cover deck: 8 backgrounds (5 licensed photos, 3 generated) plus font variants
Co-Authored-By: Claude Opus 5.5 <noreply@anthropic.com>
Claude-Session: https://claude.ai/code/session_01UMtUXS3Hcnk8npRGnNTmeK
</commit_message>
<xml_diff>
--- a/哈小琴_答辩封面_方案.pptx
+++ b/哈小琴_答辩封面_方案.pptx
@@ -10,9 +10,16 @@
     <p:sldId id="258" r:id="rId4"/>
     <p:sldId id="259" r:id="rId5"/>
     <p:sldId id="260" r:id="rId6"/>
+    <p:sldId id="261" r:id="rId7"/>
+    <p:sldId id="262" r:id="rId8"/>
+    <p:sldId id="263" r:id="rId9"/>
+    <p:sldId id="264" r:id="rId10"/>
+    <p:sldId id="265" r:id="rId11"/>
+    <p:sldId id="266" r:id="rId12"/>
+    <p:sldId id="267" r:id="rId13"/>
   </p:sldIdLst>
   <p:notesMasterIdLst>
-    <p:notesMasterId r:id="rId7"/>
+    <p:notesMasterId r:id="rId14"/>
   </p:notesMasterIdLst>
   <p:sldSz cx="12192000" cy="6858000"/>
   <p:notesSz cx="6858000" cy="12192000"/>
@@ -506,7 +513,7 @@
           <a:p>
             <a:r>
               <a:rPr lang="en-US" dirty="0"/>
-              <a:t>方案1：雅黑粗体标题 + 楷体姓名（最接近原图）</a:t>
+              <a:t>第1页｜真实照片A：粉色晚霞雪山（Pexels 1287145，Pexels许可，可免费商用）｜字体1：微软雅黑粗体标题＋楷体姓名</a:t>
             </a:r>
             <a:endParaRPr lang="en-US" dirty="0"/>
           </a:p>
@@ -530,6 +537,270 @@
             <a:fld id="{F7021451-1387-4CA6-816F-3879F97B5CBC}" type="slidenum">
               <a:rPr lang="en-US"/>
               <a:t>1</a:t>
+            </a:fld>
+            <a:endParaRPr lang="en-US"/>
+          </a:p>
+        </p:txBody>
+      </p:sp>
+    </p:spTree>
+    <p:extLst>
+      <p:ext uri="{BB962C8B-B14F-4D97-AF65-F5344CB8AC3E}">
+        <p14:creationId xmlns:p14="http://schemas.microsoft.com/office/powerpoint/2010/main" val="1024086991"/>
+      </p:ext>
+    </p:extLst>
+  </p:cSld>
+  <p:clrMapOvr>
+    <a:masterClrMapping/>
+  </p:clrMapOvr>
+</p:notes>
+</file>
+
+<file path=ppt/notesSlides/notesSlide10.xml><?xml version="1.0" encoding="utf-8"?>
+<p:notes xmlns:a="http://schemas.openxmlformats.org/drawingml/2006/main" xmlns:r="http://schemas.openxmlformats.org/officeDocument/2006/relationships" xmlns:p="http://schemas.openxmlformats.org/presentationml/2006/main">
+  <p:cSld>
+    <p:spTree>
+      <p:nvGrpSpPr>
+        <p:cNvPr id="1" name=""/>
+        <p:cNvGrpSpPr/>
+        <p:nvPr/>
+      </p:nvGrpSpPr>
+      <p:grpSpPr>
+        <a:xfrm>
+          <a:off x="0" y="0"/>
+          <a:ext cx="0" cy="0"/>
+          <a:chOff x="0" y="0"/>
+          <a:chExt cx="0" cy="0"/>
+        </a:xfrm>
+      </p:grpSpPr>
+      <p:sp>
+        <p:nvSpPr>
+          <p:cNvPr id="2" name="Slide Image Placeholder 1"/>
+          <p:cNvSpPr>
+            <a:spLocks noGrp="1" noRot="1" noChangeAspect="1"/>
+          </p:cNvSpPr>
+          <p:nvPr>
+            <p:ph type="sldImg"/>
+          </p:nvPr>
+        </p:nvSpPr>
+        <p:spPr/>
+      </p:sp>
+      <p:sp>
+        <p:nvSpPr>
+          <p:cNvPr id="3" name="Notes Placeholder 2"/>
+          <p:cNvSpPr>
+            <a:spLocks noGrp="1"/>
+          </p:cNvSpPr>
+          <p:nvPr>
+            <p:ph type="body" idx="1"/>
+          </p:nvPr>
+        </p:nvSpPr>
+        <p:spPr/>
+        <p:txBody>
+          <a:bodyPr/>
+          <a:lstStyle/>
+          <a:p>
+            <a:r>
+              <a:rPr lang="en-US" dirty="0"/>
+              <a:t>第10页｜背景同第1页｜字体3：全雅黑</a:t>
+            </a:r>
+            <a:endParaRPr lang="en-US" dirty="0"/>
+          </a:p>
+        </p:txBody>
+      </p:sp>
+      <p:sp>
+        <p:nvSpPr>
+          <p:cNvPr id="4" name="Slide Number Placeholder 3"/>
+          <p:cNvSpPr>
+            <a:spLocks noGrp="1"/>
+          </p:cNvSpPr>
+          <p:nvPr>
+            <p:ph type="sldNum" sz="quarter" idx="10"/>
+          </p:nvPr>
+        </p:nvSpPr>
+        <p:spPr/>
+        <p:txBody>
+          <a:bodyPr/>
+          <a:lstStyle/>
+          <a:p>
+            <a:fld id="{F7021451-1387-4CA6-816F-3879F97B5CBC}" type="slidenum">
+              <a:rPr lang="en-US"/>
+              <a:t>10</a:t>
+            </a:fld>
+            <a:endParaRPr lang="en-US"/>
+          </a:p>
+        </p:txBody>
+      </p:sp>
+    </p:spTree>
+    <p:extLst>
+      <p:ext uri="{BB962C8B-B14F-4D97-AF65-F5344CB8AC3E}">
+        <p14:creationId xmlns:p14="http://schemas.microsoft.com/office/powerpoint/2010/main" val="1024086991"/>
+      </p:ext>
+    </p:extLst>
+  </p:cSld>
+  <p:clrMapOvr>
+    <a:masterClrMapping/>
+  </p:clrMapOvr>
+</p:notes>
+</file>
+
+<file path=ppt/notesSlides/notesSlide11.xml><?xml version="1.0" encoding="utf-8"?>
+<p:notes xmlns:a="http://schemas.openxmlformats.org/drawingml/2006/main" xmlns:r="http://schemas.openxmlformats.org/officeDocument/2006/relationships" xmlns:p="http://schemas.openxmlformats.org/presentationml/2006/main">
+  <p:cSld>
+    <p:spTree>
+      <p:nvGrpSpPr>
+        <p:cNvPr id="1" name=""/>
+        <p:cNvGrpSpPr/>
+        <p:nvPr/>
+      </p:nvGrpSpPr>
+      <p:grpSpPr>
+        <a:xfrm>
+          <a:off x="0" y="0"/>
+          <a:ext cx="0" cy="0"/>
+          <a:chOff x="0" y="0"/>
+          <a:chExt cx="0" cy="0"/>
+        </a:xfrm>
+      </p:grpSpPr>
+      <p:sp>
+        <p:nvSpPr>
+          <p:cNvPr id="2" name="Slide Image Placeholder 1"/>
+          <p:cNvSpPr>
+            <a:spLocks noGrp="1" noRot="1" noChangeAspect="1"/>
+          </p:cNvSpPr>
+          <p:nvPr>
+            <p:ph type="sldImg"/>
+          </p:nvPr>
+        </p:nvSpPr>
+        <p:spPr/>
+      </p:sp>
+      <p:sp>
+        <p:nvSpPr>
+          <p:cNvPr id="3" name="Notes Placeholder 2"/>
+          <p:cNvSpPr>
+            <a:spLocks noGrp="1"/>
+          </p:cNvSpPr>
+          <p:nvPr>
+            <p:ph type="body" idx="1"/>
+          </p:nvPr>
+        </p:nvSpPr>
+        <p:spPr/>
+        <p:txBody>
+          <a:bodyPr/>
+          <a:lstStyle/>
+          <a:p>
+            <a:r>
+              <a:rPr lang="en-US" dirty="0"/>
+              <a:t>第11页｜背景同第1页｜字体4：思源黑体＋楷体_GB2312</a:t>
+            </a:r>
+            <a:endParaRPr lang="en-US" dirty="0"/>
+          </a:p>
+        </p:txBody>
+      </p:sp>
+      <p:sp>
+        <p:nvSpPr>
+          <p:cNvPr id="4" name="Slide Number Placeholder 3"/>
+          <p:cNvSpPr>
+            <a:spLocks noGrp="1"/>
+          </p:cNvSpPr>
+          <p:nvPr>
+            <p:ph type="sldNum" sz="quarter" idx="10"/>
+          </p:nvPr>
+        </p:nvSpPr>
+        <p:spPr/>
+        <p:txBody>
+          <a:bodyPr/>
+          <a:lstStyle/>
+          <a:p>
+            <a:fld id="{F7021451-1387-4CA6-816F-3879F97B5CBC}" type="slidenum">
+              <a:rPr lang="en-US"/>
+              <a:t>11</a:t>
+            </a:fld>
+            <a:endParaRPr lang="en-US"/>
+          </a:p>
+        </p:txBody>
+      </p:sp>
+    </p:spTree>
+    <p:extLst>
+      <p:ext uri="{BB962C8B-B14F-4D97-AF65-F5344CB8AC3E}">
+        <p14:creationId xmlns:p14="http://schemas.microsoft.com/office/powerpoint/2010/main" val="1024086991"/>
+      </p:ext>
+    </p:extLst>
+  </p:cSld>
+  <p:clrMapOvr>
+    <a:masterClrMapping/>
+  </p:clrMapOvr>
+</p:notes>
+</file>
+
+<file path=ppt/notesSlides/notesSlide12.xml><?xml version="1.0" encoding="utf-8"?>
+<p:notes xmlns:a="http://schemas.openxmlformats.org/drawingml/2006/main" xmlns:r="http://schemas.openxmlformats.org/officeDocument/2006/relationships" xmlns:p="http://schemas.openxmlformats.org/presentationml/2006/main">
+  <p:cSld>
+    <p:spTree>
+      <p:nvGrpSpPr>
+        <p:cNvPr id="1" name=""/>
+        <p:cNvGrpSpPr/>
+        <p:nvPr/>
+      </p:nvGrpSpPr>
+      <p:grpSpPr>
+        <a:xfrm>
+          <a:off x="0" y="0"/>
+          <a:ext cx="0" cy="0"/>
+          <a:chOff x="0" y="0"/>
+          <a:chExt cx="0" cy="0"/>
+        </a:xfrm>
+      </p:grpSpPr>
+      <p:sp>
+        <p:nvSpPr>
+          <p:cNvPr id="2" name="Slide Image Placeholder 1"/>
+          <p:cNvSpPr>
+            <a:spLocks noGrp="1" noRot="1" noChangeAspect="1"/>
+          </p:cNvSpPr>
+          <p:nvPr>
+            <p:ph type="sldImg"/>
+          </p:nvPr>
+        </p:nvSpPr>
+        <p:spPr/>
+      </p:sp>
+      <p:sp>
+        <p:nvSpPr>
+          <p:cNvPr id="3" name="Notes Placeholder 2"/>
+          <p:cNvSpPr>
+            <a:spLocks noGrp="1"/>
+          </p:cNvSpPr>
+          <p:nvPr>
+            <p:ph type="body" idx="1"/>
+          </p:nvPr>
+        </p:nvSpPr>
+        <p:spPr/>
+        <p:txBody>
+          <a:bodyPr/>
+          <a:lstStyle/>
+          <a:p>
+            <a:r>
+              <a:rPr lang="en-US" dirty="0"/>
+              <a:t>第12页｜背景同第1页｜字体5：雅黑标题＋仿宋姓名＋宋体单位</a:t>
+            </a:r>
+            <a:endParaRPr lang="en-US" dirty="0"/>
+          </a:p>
+        </p:txBody>
+      </p:sp>
+      <p:sp>
+        <p:nvSpPr>
+          <p:cNvPr id="4" name="Slide Number Placeholder 3"/>
+          <p:cNvSpPr>
+            <a:spLocks noGrp="1"/>
+          </p:cNvSpPr>
+          <p:nvPr>
+            <p:ph type="sldNum" sz="quarter" idx="10"/>
+          </p:nvPr>
+        </p:nvSpPr>
+        <p:spPr/>
+        <p:txBody>
+          <a:bodyPr/>
+          <a:lstStyle/>
+          <a:p>
+            <a:fld id="{F7021451-1387-4CA6-816F-3879F97B5CBC}" type="slidenum">
+              <a:rPr lang="en-US"/>
+              <a:t>12</a:t>
             </a:fld>
             <a:endParaRPr lang="en-US"/>
           </a:p>
@@ -594,7 +865,7 @@
           <a:p>
             <a:r>
               <a:rPr lang="en-US" dirty="0"/>
-              <a:t>方案2：黑体标题 + 华文楷体姓名</a:t>
+              <a:t>第2页｜真实照片B：云雾灰调雪山（Pexels 691668，Pexels许可，可免费商用）｜字体1：微软雅黑粗体标题＋楷体姓名</a:t>
             </a:r>
             <a:endParaRPr lang="en-US" dirty="0"/>
           </a:p>
@@ -682,7 +953,7 @@
           <a:p>
             <a:r>
               <a:rPr lang="en-US" dirty="0"/>
-              <a:t>方案3：全雅黑，姓名用雅黑常规体</a:t>
+              <a:t>第3页｜真实照片C：蓝天白云雪峰（Unsplash photo-1454496522488，Unsplash许可，可免费商用）｜字体1：微软雅黑粗体标题＋楷体姓名</a:t>
             </a:r>
             <a:endParaRPr lang="en-US" dirty="0"/>
           </a:p>
@@ -770,7 +1041,7 @@
           <a:p>
             <a:r>
               <a:rPr lang="en-US" dirty="0"/>
-              <a:t>方案4：思源黑体标题 + 楷体_GB2312姓名</a:t>
+              <a:t>第4页｜真实照片D：云海群峰（Unsplash photo-1458668383970，Unsplash许可，可免费商用）｜字体1：微软雅黑粗体标题＋楷体姓名</a:t>
             </a:r>
             <a:endParaRPr lang="en-US" dirty="0"/>
           </a:p>
@@ -858,7 +1129,7 @@
           <a:p>
             <a:r>
               <a:rPr lang="en-US" dirty="0"/>
-              <a:t>方案5：雅黑标题 + 仿宋姓名 + 宋体单位</a:t>
+              <a:t>第5页｜真实照片E：日落云海（Unsplash photo-1506905925346，Unsplash许可，可免费商用）｜字体1：微软雅黑粗体标题＋楷体姓名</a:t>
             </a:r>
             <a:endParaRPr lang="en-US" dirty="0"/>
           </a:p>
@@ -882,6 +1153,358 @@
             <a:fld id="{F7021451-1387-4CA6-816F-3879F97B5CBC}" type="slidenum">
               <a:rPr lang="en-US"/>
               <a:t>5</a:t>
+            </a:fld>
+            <a:endParaRPr lang="en-US"/>
+          </a:p>
+        </p:txBody>
+      </p:sp>
+    </p:spTree>
+    <p:extLst>
+      <p:ext uri="{BB962C8B-B14F-4D97-AF65-F5344CB8AC3E}">
+        <p14:creationId xmlns:p14="http://schemas.microsoft.com/office/powerpoint/2010/main" val="1024086991"/>
+      </p:ext>
+    </p:extLst>
+  </p:cSld>
+  <p:clrMapOvr>
+    <a:masterClrMapping/>
+  </p:clrMapOvr>
+</p:notes>
+</file>
+
+<file path=ppt/notesSlides/notesSlide6.xml><?xml version="1.0" encoding="utf-8"?>
+<p:notes xmlns:a="http://schemas.openxmlformats.org/drawingml/2006/main" xmlns:r="http://schemas.openxmlformats.org/officeDocument/2006/relationships" xmlns:p="http://schemas.openxmlformats.org/presentationml/2006/main">
+  <p:cSld>
+    <p:spTree>
+      <p:nvGrpSpPr>
+        <p:cNvPr id="1" name=""/>
+        <p:cNvGrpSpPr/>
+        <p:nvPr/>
+      </p:nvGrpSpPr>
+      <p:grpSpPr>
+        <a:xfrm>
+          <a:off x="0" y="0"/>
+          <a:ext cx="0" cy="0"/>
+          <a:chOff x="0" y="0"/>
+          <a:chExt cx="0" cy="0"/>
+        </a:xfrm>
+      </p:grpSpPr>
+      <p:sp>
+        <p:nvSpPr>
+          <p:cNvPr id="2" name="Slide Image Placeholder 1"/>
+          <p:cNvSpPr>
+            <a:spLocks noGrp="1" noRot="1" noChangeAspect="1"/>
+          </p:cNvSpPr>
+          <p:nvPr>
+            <p:ph type="sldImg"/>
+          </p:nvPr>
+        </p:nvSpPr>
+        <p:spPr/>
+      </p:sp>
+      <p:sp>
+        <p:nvSpPr>
+          <p:cNvPr id="3" name="Notes Placeholder 2"/>
+          <p:cNvSpPr>
+            <a:spLocks noGrp="1"/>
+          </p:cNvSpPr>
+          <p:nvPr>
+            <p:ph type="body" idx="1"/>
+          </p:nvPr>
+        </p:nvSpPr>
+        <p:spPr/>
+        <p:txBody>
+          <a:bodyPr/>
+          <a:lstStyle/>
+          <a:p>
+            <a:r>
+              <a:rPr lang="en-US" dirty="0"/>
+              <a:t>第6页｜程序渲染F：粉霞云海孤峰（三维地形程序渲染，原创）｜字体1：微软雅黑粗体标题＋楷体姓名</a:t>
+            </a:r>
+            <a:endParaRPr lang="en-US" dirty="0"/>
+          </a:p>
+        </p:txBody>
+      </p:sp>
+      <p:sp>
+        <p:nvSpPr>
+          <p:cNvPr id="4" name="Slide Number Placeholder 3"/>
+          <p:cNvSpPr>
+            <a:spLocks noGrp="1"/>
+          </p:cNvSpPr>
+          <p:nvPr>
+            <p:ph type="sldNum" sz="quarter" idx="10"/>
+          </p:nvPr>
+        </p:nvSpPr>
+        <p:spPr/>
+        <p:txBody>
+          <a:bodyPr/>
+          <a:lstStyle/>
+          <a:p>
+            <a:fld id="{F7021451-1387-4CA6-816F-3879F97B5CBC}" type="slidenum">
+              <a:rPr lang="en-US"/>
+              <a:t>6</a:t>
+            </a:fld>
+            <a:endParaRPr lang="en-US"/>
+          </a:p>
+        </p:txBody>
+      </p:sp>
+    </p:spTree>
+    <p:extLst>
+      <p:ext uri="{BB962C8B-B14F-4D97-AF65-F5344CB8AC3E}">
+        <p14:creationId xmlns:p14="http://schemas.microsoft.com/office/powerpoint/2010/main" val="1024086991"/>
+      </p:ext>
+    </p:extLst>
+  </p:cSld>
+  <p:clrMapOvr>
+    <a:masterClrMapping/>
+  </p:clrMapOvr>
+</p:notes>
+</file>
+
+<file path=ppt/notesSlides/notesSlide7.xml><?xml version="1.0" encoding="utf-8"?>
+<p:notes xmlns:a="http://schemas.openxmlformats.org/drawingml/2006/main" xmlns:r="http://schemas.openxmlformats.org/officeDocument/2006/relationships" xmlns:p="http://schemas.openxmlformats.org/presentationml/2006/main">
+  <p:cSld>
+    <p:spTree>
+      <p:nvGrpSpPr>
+        <p:cNvPr id="1" name=""/>
+        <p:cNvGrpSpPr/>
+        <p:nvPr/>
+      </p:nvGrpSpPr>
+      <p:grpSpPr>
+        <a:xfrm>
+          <a:off x="0" y="0"/>
+          <a:ext cx="0" cy="0"/>
+          <a:chOff x="0" y="0"/>
+          <a:chExt cx="0" cy="0"/>
+        </a:xfrm>
+      </p:grpSpPr>
+      <p:sp>
+        <p:nvSpPr>
+          <p:cNvPr id="2" name="Slide Image Placeholder 1"/>
+          <p:cNvSpPr>
+            <a:spLocks noGrp="1" noRot="1" noChangeAspect="1"/>
+          </p:cNvSpPr>
+          <p:nvPr>
+            <p:ph type="sldImg"/>
+          </p:nvPr>
+        </p:nvSpPr>
+        <p:spPr/>
+      </p:sp>
+      <p:sp>
+        <p:nvSpPr>
+          <p:cNvPr id="3" name="Notes Placeholder 2"/>
+          <p:cNvSpPr>
+            <a:spLocks noGrp="1"/>
+          </p:cNvSpPr>
+          <p:nvPr>
+            <p:ph type="body" idx="1"/>
+          </p:nvPr>
+        </p:nvSpPr>
+        <p:spPr/>
+        <p:txBody>
+          <a:bodyPr/>
+          <a:lstStyle/>
+          <a:p>
+            <a:r>
+              <a:rPr lang="en-US" dirty="0"/>
+              <a:t>第7页｜程序渲染G：淡蓝云海群峰（三维地形程序渲染，原创）｜字体1：微软雅黑粗体标题＋楷体姓名</a:t>
+            </a:r>
+            <a:endParaRPr lang="en-US" dirty="0"/>
+          </a:p>
+        </p:txBody>
+      </p:sp>
+      <p:sp>
+        <p:nvSpPr>
+          <p:cNvPr id="4" name="Slide Number Placeholder 3"/>
+          <p:cNvSpPr>
+            <a:spLocks noGrp="1"/>
+          </p:cNvSpPr>
+          <p:nvPr>
+            <p:ph type="sldNum" sz="quarter" idx="10"/>
+          </p:nvPr>
+        </p:nvSpPr>
+        <p:spPr/>
+        <p:txBody>
+          <a:bodyPr/>
+          <a:lstStyle/>
+          <a:p>
+            <a:fld id="{F7021451-1387-4CA6-816F-3879F97B5CBC}" type="slidenum">
+              <a:rPr lang="en-US"/>
+              <a:t>7</a:t>
+            </a:fld>
+            <a:endParaRPr lang="en-US"/>
+          </a:p>
+        </p:txBody>
+      </p:sp>
+    </p:spTree>
+    <p:extLst>
+      <p:ext uri="{BB962C8B-B14F-4D97-AF65-F5344CB8AC3E}">
+        <p14:creationId xmlns:p14="http://schemas.microsoft.com/office/powerpoint/2010/main" val="1024086991"/>
+      </p:ext>
+    </p:extLst>
+  </p:cSld>
+  <p:clrMapOvr>
+    <a:masterClrMapping/>
+  </p:clrMapOvr>
+</p:notes>
+</file>
+
+<file path=ppt/notesSlides/notesSlide8.xml><?xml version="1.0" encoding="utf-8"?>
+<p:notes xmlns:a="http://schemas.openxmlformats.org/drawingml/2006/main" xmlns:r="http://schemas.openxmlformats.org/officeDocument/2006/relationships" xmlns:p="http://schemas.openxmlformats.org/presentationml/2006/main">
+  <p:cSld>
+    <p:spTree>
+      <p:nvGrpSpPr>
+        <p:cNvPr id="1" name=""/>
+        <p:cNvGrpSpPr/>
+        <p:nvPr/>
+      </p:nvGrpSpPr>
+      <p:grpSpPr>
+        <a:xfrm>
+          <a:off x="0" y="0"/>
+          <a:ext cx="0" cy="0"/>
+          <a:chOff x="0" y="0"/>
+          <a:chExt cx="0" cy="0"/>
+        </a:xfrm>
+      </p:grpSpPr>
+      <p:sp>
+        <p:nvSpPr>
+          <p:cNvPr id="2" name="Slide Image Placeholder 1"/>
+          <p:cNvSpPr>
+            <a:spLocks noGrp="1" noRot="1" noChangeAspect="1"/>
+          </p:cNvSpPr>
+          <p:nvPr>
+            <p:ph type="sldImg"/>
+          </p:nvPr>
+        </p:nvSpPr>
+        <p:spPr/>
+      </p:sp>
+      <p:sp>
+        <p:nvSpPr>
+          <p:cNvPr id="3" name="Notes Placeholder 2"/>
+          <p:cNvSpPr>
+            <a:spLocks noGrp="1"/>
+          </p:cNvSpPr>
+          <p:nvPr>
+            <p:ph type="body" idx="1"/>
+          </p:nvPr>
+        </p:nvSpPr>
+        <p:spPr/>
+        <p:txBody>
+          <a:bodyPr/>
+          <a:lstStyle/>
+          <a:p>
+            <a:r>
+              <a:rPr lang="en-US" dirty="0"/>
+              <a:t>第8页｜程序生成H：水墨雪山（原创）｜字体1：微软雅黑粗体标题＋楷体姓名</a:t>
+            </a:r>
+            <a:endParaRPr lang="en-US" dirty="0"/>
+          </a:p>
+        </p:txBody>
+      </p:sp>
+      <p:sp>
+        <p:nvSpPr>
+          <p:cNvPr id="4" name="Slide Number Placeholder 3"/>
+          <p:cNvSpPr>
+            <a:spLocks noGrp="1"/>
+          </p:cNvSpPr>
+          <p:nvPr>
+            <p:ph type="sldNum" sz="quarter" idx="10"/>
+          </p:nvPr>
+        </p:nvSpPr>
+        <p:spPr/>
+        <p:txBody>
+          <a:bodyPr/>
+          <a:lstStyle/>
+          <a:p>
+            <a:fld id="{F7021451-1387-4CA6-816F-3879F97B5CBC}" type="slidenum">
+              <a:rPr lang="en-US"/>
+              <a:t>8</a:t>
+            </a:fld>
+            <a:endParaRPr lang="en-US"/>
+          </a:p>
+        </p:txBody>
+      </p:sp>
+    </p:spTree>
+    <p:extLst>
+      <p:ext uri="{BB962C8B-B14F-4D97-AF65-F5344CB8AC3E}">
+        <p14:creationId xmlns:p14="http://schemas.microsoft.com/office/powerpoint/2010/main" val="1024086991"/>
+      </p:ext>
+    </p:extLst>
+  </p:cSld>
+  <p:clrMapOvr>
+    <a:masterClrMapping/>
+  </p:clrMapOvr>
+</p:notes>
+</file>
+
+<file path=ppt/notesSlides/notesSlide9.xml><?xml version="1.0" encoding="utf-8"?>
+<p:notes xmlns:a="http://schemas.openxmlformats.org/drawingml/2006/main" xmlns:r="http://schemas.openxmlformats.org/officeDocument/2006/relationships" xmlns:p="http://schemas.openxmlformats.org/presentationml/2006/main">
+  <p:cSld>
+    <p:spTree>
+      <p:nvGrpSpPr>
+        <p:cNvPr id="1" name=""/>
+        <p:cNvGrpSpPr/>
+        <p:nvPr/>
+      </p:nvGrpSpPr>
+      <p:grpSpPr>
+        <a:xfrm>
+          <a:off x="0" y="0"/>
+          <a:ext cx="0" cy="0"/>
+          <a:chOff x="0" y="0"/>
+          <a:chExt cx="0" cy="0"/>
+        </a:xfrm>
+      </p:grpSpPr>
+      <p:sp>
+        <p:nvSpPr>
+          <p:cNvPr id="2" name="Slide Image Placeholder 1"/>
+          <p:cNvSpPr>
+            <a:spLocks noGrp="1" noRot="1" noChangeAspect="1"/>
+          </p:cNvSpPr>
+          <p:nvPr>
+            <p:ph type="sldImg"/>
+          </p:nvPr>
+        </p:nvSpPr>
+        <p:spPr/>
+      </p:sp>
+      <p:sp>
+        <p:nvSpPr>
+          <p:cNvPr id="3" name="Notes Placeholder 2"/>
+          <p:cNvSpPr>
+            <a:spLocks noGrp="1"/>
+          </p:cNvSpPr>
+          <p:nvPr>
+            <p:ph type="body" idx="1"/>
+          </p:nvPr>
+        </p:nvSpPr>
+        <p:spPr/>
+        <p:txBody>
+          <a:bodyPr/>
+          <a:lstStyle/>
+          <a:p>
+            <a:r>
+              <a:rPr lang="en-US" dirty="0"/>
+              <a:t>第9页｜背景同第1页｜字体2：黑体标题＋华文楷体姓名</a:t>
+            </a:r>
+            <a:endParaRPr lang="en-US" dirty="0"/>
+          </a:p>
+        </p:txBody>
+      </p:sp>
+      <p:sp>
+        <p:nvSpPr>
+          <p:cNvPr id="4" name="Slide Number Placeholder 3"/>
+          <p:cNvSpPr>
+            <a:spLocks noGrp="1"/>
+          </p:cNvSpPr>
+          <p:nvPr>
+            <p:ph type="sldNum" sz="quarter" idx="10"/>
+          </p:nvPr>
+        </p:nvSpPr>
+        <p:spPr/>
+        <p:txBody>
+          <a:bodyPr/>
+          <a:lstStyle/>
+          <a:p>
+            <a:fld id="{F7021451-1387-4CA6-816F-3879F97B5CBC}" type="slidenum">
+              <a:rPr lang="en-US"/>
+              <a:t>9</a:t>
             </a:fld>
             <a:endParaRPr lang="en-US"/>
           </a:p>
@@ -1363,6 +1986,474 @@
 </p:sld>
 </file>
 
+<file path=ppt/slides/slide10.xml><?xml version="1.0" encoding="utf-8"?>
+<p:sld xmlns:a="http://schemas.openxmlformats.org/drawingml/2006/main" xmlns:r="http://schemas.openxmlformats.org/officeDocument/2006/relationships" xmlns:p="http://schemas.openxmlformats.org/presentationml/2006/main">
+  <p:cSld name="Slide 10">
+    <p:bg>
+      <p:bgPr>
+        <a:blipFill dpi="0" rotWithShape="1">
+          <a:blip r:embed="rId1">
+            <a:lum/>
+          </a:blip>
+          <a:srcRect/>
+          <a:stretch>
+            <a:fillRect/>
+          </a:stretch>
+        </a:blipFill>
+        <a:effectLst/>
+      </p:bgPr>
+    </p:bg>
+    <p:spTree>
+      <p:nvGrpSpPr>
+        <p:cNvPr id="1" name=""/>
+        <p:cNvGrpSpPr/>
+        <p:nvPr/>
+      </p:nvGrpSpPr>
+      <p:grpSpPr>
+        <a:xfrm>
+          <a:off x="0" y="0"/>
+          <a:ext cx="0" cy="0"/>
+          <a:chOff x="0" y="0"/>
+          <a:chExt cx="0" cy="0"/>
+        </a:xfrm>
+      </p:grpSpPr>
+      <p:sp>
+        <p:nvSpPr>
+          <p:cNvPr id="2" name="标题"/>
+          <p:cNvSpPr txBox="1"/>
+          <p:nvPr/>
+        </p:nvSpPr>
+        <p:spPr>
+          <a:xfrm>
+            <a:off x="274320" y="1691640"/>
+            <a:ext cx="11640312" cy="914400"/>
+          </a:xfrm>
+          <a:prstGeom prst="rect">
+            <a:avLst/>
+          </a:prstGeom>
+          <a:noFill/>
+          <a:ln/>
+        </p:spPr>
+        <p:txBody>
+          <a:bodyPr wrap="square" lIns="0" tIns="0" rIns="0" bIns="0" rtlCol="0" anchor="ctr"/>
+          <a:lstStyle/>
+          <a:p>
+            <a:pPr algn="ctr" indent="0" marL="0">
+              <a:buNone/>
+            </a:pPr>
+            <a:r>
+              <a:rPr lang="en-US" sz="6000" b="1" dirty="0">
+                <a:solidFill>
+                  <a:srgbClr val="2F3A55"/>
+                </a:solidFill>
+                <a:latin typeface="Microsoft YaHei" pitchFamily="34" charset="0"/>
+                <a:ea typeface="Microsoft YaHei" pitchFamily="34" charset="-122"/>
+                <a:cs typeface="Microsoft YaHei" pitchFamily="34" charset="-120"/>
+              </a:rPr>
+              <a:t>军队专业技术待遇五级选升答辩</a:t>
+            </a:r>
+            <a:endParaRPr lang="en-US" sz="6000" dirty="0"/>
+          </a:p>
+        </p:txBody>
+      </p:sp>
+      <p:sp>
+        <p:nvSpPr>
+          <p:cNvPr id="3" name="姓名"/>
+          <p:cNvSpPr txBox="1"/>
+          <p:nvPr/>
+        </p:nvSpPr>
+        <p:spPr>
+          <a:xfrm>
+            <a:off x="3355848" y="3520440"/>
+            <a:ext cx="5486400" cy="822960"/>
+          </a:xfrm>
+          <a:prstGeom prst="rect">
+            <a:avLst/>
+          </a:prstGeom>
+          <a:noFill/>
+          <a:ln/>
+        </p:spPr>
+        <p:txBody>
+          <a:bodyPr wrap="square" lIns="0" tIns="0" rIns="0" bIns="0" rtlCol="0" anchor="ctr"/>
+          <a:lstStyle/>
+          <a:p>
+            <a:pPr algn="ctr" indent="0" marL="0">
+              <a:buNone/>
+            </a:pPr>
+            <a:r>
+              <a:rPr lang="en-US" sz="4400" dirty="0">
+                <a:solidFill>
+                  <a:srgbClr val="33566B"/>
+                </a:solidFill>
+                <a:latin typeface="Microsoft YaHei" pitchFamily="34" charset="0"/>
+                <a:ea typeface="Microsoft YaHei" pitchFamily="34" charset="-122"/>
+                <a:cs typeface="Microsoft YaHei" pitchFamily="34" charset="-120"/>
+              </a:rPr>
+              <a:t>哈　小　琴</a:t>
+            </a:r>
+            <a:endParaRPr lang="en-US" sz="4400" dirty="0"/>
+          </a:p>
+        </p:txBody>
+      </p:sp>
+      <p:sp>
+        <p:nvSpPr>
+          <p:cNvPr id="4" name="单位"/>
+          <p:cNvSpPr txBox="1"/>
+          <p:nvPr/>
+        </p:nvSpPr>
+        <p:spPr>
+          <a:xfrm>
+            <a:off x="2441448" y="4343400"/>
+            <a:ext cx="7315200" cy="731520"/>
+          </a:xfrm>
+          <a:prstGeom prst="rect">
+            <a:avLst/>
+          </a:prstGeom>
+          <a:noFill/>
+          <a:ln/>
+        </p:spPr>
+        <p:txBody>
+          <a:bodyPr wrap="square" lIns="0" tIns="0" rIns="0" bIns="0" rtlCol="0" anchor="ctr"/>
+          <a:lstStyle/>
+          <a:p>
+            <a:pPr algn="ctr" indent="0" marL="0">
+              <a:buNone/>
+            </a:pPr>
+            <a:r>
+              <a:rPr lang="en-US" sz="2800" dirty="0">
+                <a:solidFill>
+                  <a:srgbClr val="3D5A6A"/>
+                </a:solidFill>
+                <a:latin typeface="Microsoft YaHei" pitchFamily="34" charset="0"/>
+                <a:ea typeface="Microsoft YaHei" pitchFamily="34" charset="-122"/>
+                <a:cs typeface="Microsoft YaHei" pitchFamily="34" charset="-120"/>
+              </a:rPr>
+              <a:t>联勤保障部队第九四〇医院</a:t>
+            </a:r>
+            <a:endParaRPr lang="en-US" sz="2800" dirty="0"/>
+          </a:p>
+        </p:txBody>
+      </p:sp>
+    </p:spTree>
+  </p:cSld>
+  <p:clrMapOvr>
+    <a:masterClrMapping/>
+  </p:clrMapOvr>
+</p:sld>
+</file>
+
+<file path=ppt/slides/slide11.xml><?xml version="1.0" encoding="utf-8"?>
+<p:sld xmlns:a="http://schemas.openxmlformats.org/drawingml/2006/main" xmlns:r="http://schemas.openxmlformats.org/officeDocument/2006/relationships" xmlns:p="http://schemas.openxmlformats.org/presentationml/2006/main">
+  <p:cSld name="Slide 11">
+    <p:bg>
+      <p:bgPr>
+        <a:blipFill dpi="0" rotWithShape="1">
+          <a:blip r:embed="rId1">
+            <a:lum/>
+          </a:blip>
+          <a:srcRect/>
+          <a:stretch>
+            <a:fillRect/>
+          </a:stretch>
+        </a:blipFill>
+        <a:effectLst/>
+      </p:bgPr>
+    </p:bg>
+    <p:spTree>
+      <p:nvGrpSpPr>
+        <p:cNvPr id="1" name=""/>
+        <p:cNvGrpSpPr/>
+        <p:nvPr/>
+      </p:nvGrpSpPr>
+      <p:grpSpPr>
+        <a:xfrm>
+          <a:off x="0" y="0"/>
+          <a:ext cx="0" cy="0"/>
+          <a:chOff x="0" y="0"/>
+          <a:chExt cx="0" cy="0"/>
+        </a:xfrm>
+      </p:grpSpPr>
+      <p:sp>
+        <p:nvSpPr>
+          <p:cNvPr id="2" name="标题"/>
+          <p:cNvSpPr txBox="1"/>
+          <p:nvPr/>
+        </p:nvSpPr>
+        <p:spPr>
+          <a:xfrm>
+            <a:off x="274320" y="1691640"/>
+            <a:ext cx="11640312" cy="914400"/>
+          </a:xfrm>
+          <a:prstGeom prst="rect">
+            <a:avLst/>
+          </a:prstGeom>
+          <a:noFill/>
+          <a:ln/>
+        </p:spPr>
+        <p:txBody>
+          <a:bodyPr wrap="square" lIns="0" tIns="0" rIns="0" bIns="0" rtlCol="0" anchor="ctr"/>
+          <a:lstStyle/>
+          <a:p>
+            <a:pPr algn="ctr" indent="0" marL="0">
+              <a:buNone/>
+            </a:pPr>
+            <a:r>
+              <a:rPr lang="en-US" sz="6000" b="1" dirty="0">
+                <a:solidFill>
+                  <a:srgbClr val="2F3A55"/>
+                </a:solidFill>
+                <a:latin typeface="Source Han Sans CN" pitchFamily="34" charset="0"/>
+                <a:ea typeface="Source Han Sans CN" pitchFamily="34" charset="-122"/>
+                <a:cs typeface="Source Han Sans CN" pitchFamily="34" charset="-120"/>
+              </a:rPr>
+              <a:t>军队专业技术待遇五级选升答辩</a:t>
+            </a:r>
+            <a:endParaRPr lang="en-US" sz="6000" dirty="0"/>
+          </a:p>
+        </p:txBody>
+      </p:sp>
+      <p:sp>
+        <p:nvSpPr>
+          <p:cNvPr id="3" name="姓名"/>
+          <p:cNvSpPr txBox="1"/>
+          <p:nvPr/>
+        </p:nvSpPr>
+        <p:spPr>
+          <a:xfrm>
+            <a:off x="3355848" y="3520440"/>
+            <a:ext cx="5486400" cy="822960"/>
+          </a:xfrm>
+          <a:prstGeom prst="rect">
+            <a:avLst/>
+          </a:prstGeom>
+          <a:noFill/>
+          <a:ln/>
+        </p:spPr>
+        <p:txBody>
+          <a:bodyPr wrap="square" lIns="0" tIns="0" rIns="0" bIns="0" rtlCol="0" anchor="ctr"/>
+          <a:lstStyle/>
+          <a:p>
+            <a:pPr algn="ctr" indent="0" marL="0">
+              <a:buNone/>
+            </a:pPr>
+            <a:r>
+              <a:rPr lang="en-US" sz="4400" dirty="0">
+                <a:solidFill>
+                  <a:srgbClr val="33566B"/>
+                </a:solidFill>
+                <a:latin typeface="KaiTi_GB2312" pitchFamily="34" charset="0"/>
+                <a:ea typeface="KaiTi_GB2312" pitchFamily="34" charset="-122"/>
+                <a:cs typeface="KaiTi_GB2312" pitchFamily="34" charset="-120"/>
+              </a:rPr>
+              <a:t>哈　小　琴</a:t>
+            </a:r>
+            <a:endParaRPr lang="en-US" sz="4400" dirty="0"/>
+          </a:p>
+        </p:txBody>
+      </p:sp>
+      <p:sp>
+        <p:nvSpPr>
+          <p:cNvPr id="4" name="单位"/>
+          <p:cNvSpPr txBox="1"/>
+          <p:nvPr/>
+        </p:nvSpPr>
+        <p:spPr>
+          <a:xfrm>
+            <a:off x="2441448" y="4343400"/>
+            <a:ext cx="7315200" cy="731520"/>
+          </a:xfrm>
+          <a:prstGeom prst="rect">
+            <a:avLst/>
+          </a:prstGeom>
+          <a:noFill/>
+          <a:ln/>
+        </p:spPr>
+        <p:txBody>
+          <a:bodyPr wrap="square" lIns="0" tIns="0" rIns="0" bIns="0" rtlCol="0" anchor="ctr"/>
+          <a:lstStyle/>
+          <a:p>
+            <a:pPr algn="ctr" indent="0" marL="0">
+              <a:buNone/>
+            </a:pPr>
+            <a:r>
+              <a:rPr lang="en-US" sz="2800" dirty="0">
+                <a:solidFill>
+                  <a:srgbClr val="3D5A6A"/>
+                </a:solidFill>
+                <a:latin typeface="Source Han Sans CN" pitchFamily="34" charset="0"/>
+                <a:ea typeface="Source Han Sans CN" pitchFamily="34" charset="-122"/>
+                <a:cs typeface="Source Han Sans CN" pitchFamily="34" charset="-120"/>
+              </a:rPr>
+              <a:t>联勤保障部队第九四〇医院</a:t>
+            </a:r>
+            <a:endParaRPr lang="en-US" sz="2800" dirty="0"/>
+          </a:p>
+        </p:txBody>
+      </p:sp>
+    </p:spTree>
+  </p:cSld>
+  <p:clrMapOvr>
+    <a:masterClrMapping/>
+  </p:clrMapOvr>
+</p:sld>
+</file>
+
+<file path=ppt/slides/slide12.xml><?xml version="1.0" encoding="utf-8"?>
+<p:sld xmlns:a="http://schemas.openxmlformats.org/drawingml/2006/main" xmlns:r="http://schemas.openxmlformats.org/officeDocument/2006/relationships" xmlns:p="http://schemas.openxmlformats.org/presentationml/2006/main">
+  <p:cSld name="Slide 12">
+    <p:bg>
+      <p:bgPr>
+        <a:blipFill dpi="0" rotWithShape="1">
+          <a:blip r:embed="rId1">
+            <a:lum/>
+          </a:blip>
+          <a:srcRect/>
+          <a:stretch>
+            <a:fillRect/>
+          </a:stretch>
+        </a:blipFill>
+        <a:effectLst/>
+      </p:bgPr>
+    </p:bg>
+    <p:spTree>
+      <p:nvGrpSpPr>
+        <p:cNvPr id="1" name=""/>
+        <p:cNvGrpSpPr/>
+        <p:nvPr/>
+      </p:nvGrpSpPr>
+      <p:grpSpPr>
+        <a:xfrm>
+          <a:off x="0" y="0"/>
+          <a:ext cx="0" cy="0"/>
+          <a:chOff x="0" y="0"/>
+          <a:chExt cx="0" cy="0"/>
+        </a:xfrm>
+      </p:grpSpPr>
+      <p:sp>
+        <p:nvSpPr>
+          <p:cNvPr id="2" name="标题"/>
+          <p:cNvSpPr txBox="1"/>
+          <p:nvPr/>
+        </p:nvSpPr>
+        <p:spPr>
+          <a:xfrm>
+            <a:off x="274320" y="1691640"/>
+            <a:ext cx="11640312" cy="914400"/>
+          </a:xfrm>
+          <a:prstGeom prst="rect">
+            <a:avLst/>
+          </a:prstGeom>
+          <a:noFill/>
+          <a:ln/>
+        </p:spPr>
+        <p:txBody>
+          <a:bodyPr wrap="square" lIns="0" tIns="0" rIns="0" bIns="0" rtlCol="0" anchor="ctr"/>
+          <a:lstStyle/>
+          <a:p>
+            <a:pPr algn="ctr" indent="0" marL="0">
+              <a:buNone/>
+            </a:pPr>
+            <a:r>
+              <a:rPr lang="en-US" sz="6000" b="1" dirty="0">
+                <a:solidFill>
+                  <a:srgbClr val="2F3A55"/>
+                </a:solidFill>
+                <a:latin typeface="Microsoft YaHei" pitchFamily="34" charset="0"/>
+                <a:ea typeface="Microsoft YaHei" pitchFamily="34" charset="-122"/>
+                <a:cs typeface="Microsoft YaHei" pitchFamily="34" charset="-120"/>
+              </a:rPr>
+              <a:t>军队专业技术待遇五级选升答辩</a:t>
+            </a:r>
+            <a:endParaRPr lang="en-US" sz="6000" dirty="0"/>
+          </a:p>
+        </p:txBody>
+      </p:sp>
+      <p:sp>
+        <p:nvSpPr>
+          <p:cNvPr id="3" name="姓名"/>
+          <p:cNvSpPr txBox="1"/>
+          <p:nvPr/>
+        </p:nvSpPr>
+        <p:spPr>
+          <a:xfrm>
+            <a:off x="3355848" y="3520440"/>
+            <a:ext cx="5486400" cy="822960"/>
+          </a:xfrm>
+          <a:prstGeom prst="rect">
+            <a:avLst/>
+          </a:prstGeom>
+          <a:noFill/>
+          <a:ln/>
+        </p:spPr>
+        <p:txBody>
+          <a:bodyPr wrap="square" lIns="0" tIns="0" rIns="0" bIns="0" rtlCol="0" anchor="ctr"/>
+          <a:lstStyle/>
+          <a:p>
+            <a:pPr algn="ctr" indent="0" marL="0">
+              <a:buNone/>
+            </a:pPr>
+            <a:r>
+              <a:rPr lang="en-US" sz="4400" dirty="0">
+                <a:solidFill>
+                  <a:srgbClr val="33566B"/>
+                </a:solidFill>
+                <a:latin typeface="FangSong" pitchFamily="34" charset="0"/>
+                <a:ea typeface="FangSong" pitchFamily="34" charset="-122"/>
+                <a:cs typeface="FangSong" pitchFamily="34" charset="-120"/>
+              </a:rPr>
+              <a:t>哈　小　琴</a:t>
+            </a:r>
+            <a:endParaRPr lang="en-US" sz="4400" dirty="0"/>
+          </a:p>
+        </p:txBody>
+      </p:sp>
+      <p:sp>
+        <p:nvSpPr>
+          <p:cNvPr id="4" name="单位"/>
+          <p:cNvSpPr txBox="1"/>
+          <p:nvPr/>
+        </p:nvSpPr>
+        <p:spPr>
+          <a:xfrm>
+            <a:off x="2441448" y="4343400"/>
+            <a:ext cx="7315200" cy="731520"/>
+          </a:xfrm>
+          <a:prstGeom prst="rect">
+            <a:avLst/>
+          </a:prstGeom>
+          <a:noFill/>
+          <a:ln/>
+        </p:spPr>
+        <p:txBody>
+          <a:bodyPr wrap="square" lIns="0" tIns="0" rIns="0" bIns="0" rtlCol="0" anchor="ctr"/>
+          <a:lstStyle/>
+          <a:p>
+            <a:pPr algn="ctr" indent="0" marL="0">
+              <a:buNone/>
+            </a:pPr>
+            <a:r>
+              <a:rPr lang="en-US" sz="2800" dirty="0">
+                <a:solidFill>
+                  <a:srgbClr val="3D5A6A"/>
+                </a:solidFill>
+                <a:latin typeface="SimSun" pitchFamily="34" charset="0"/>
+                <a:ea typeface="SimSun" pitchFamily="34" charset="-122"/>
+                <a:cs typeface="SimSun" pitchFamily="34" charset="-120"/>
+              </a:rPr>
+              <a:t>联勤保障部队第九四〇医院</a:t>
+            </a:r>
+            <a:endParaRPr lang="en-US" sz="2800" dirty="0"/>
+          </a:p>
+        </p:txBody>
+      </p:sp>
+    </p:spTree>
+  </p:cSld>
+  <p:clrMapOvr>
+    <a:masterClrMapping/>
+  </p:clrMapOvr>
+</p:sld>
+</file>
+
 <file path=ppt/slides/slide2.xml><?xml version="1.0" encoding="utf-8"?>
 <p:sld xmlns:a="http://schemas.openxmlformats.org/drawingml/2006/main" xmlns:r="http://schemas.openxmlformats.org/officeDocument/2006/relationships" xmlns:p="http://schemas.openxmlformats.org/presentationml/2006/main">
   <p:cSld name="Slide 2">
@@ -1423,9 +2514,9 @@
                 <a:solidFill>
                   <a:srgbClr val="2F3A55"/>
                 </a:solidFill>
-                <a:latin typeface="SimHei" pitchFamily="34" charset="0"/>
-                <a:ea typeface="SimHei" pitchFamily="34" charset="-122"/>
-                <a:cs typeface="SimHei" pitchFamily="34" charset="-120"/>
+                <a:latin typeface="Microsoft YaHei" pitchFamily="34" charset="0"/>
+                <a:ea typeface="Microsoft YaHei" pitchFamily="34" charset="-122"/>
+                <a:cs typeface="Microsoft YaHei" pitchFamily="34" charset="-120"/>
               </a:rPr>
               <a:t>军队专业技术待遇五级选升答辩</a:t>
             </a:r>
@@ -1462,9 +2553,9 @@
                 <a:solidFill>
                   <a:srgbClr val="33566B"/>
                 </a:solidFill>
-                <a:latin typeface="STKaiti" pitchFamily="34" charset="0"/>
-                <a:ea typeface="STKaiti" pitchFamily="34" charset="-122"/>
-                <a:cs typeface="STKaiti" pitchFamily="34" charset="-120"/>
+                <a:latin typeface="KaiTi" pitchFamily="34" charset="0"/>
+                <a:ea typeface="KaiTi" pitchFamily="34" charset="-122"/>
+                <a:cs typeface="KaiTi" pitchFamily="34" charset="-120"/>
               </a:rPr>
               <a:t>哈　小　琴</a:t>
             </a:r>
@@ -1501,9 +2592,9 @@
                 <a:solidFill>
                   <a:srgbClr val="3D5A6A"/>
                 </a:solidFill>
-                <a:latin typeface="SimHei" pitchFamily="34" charset="0"/>
-                <a:ea typeface="SimHei" pitchFamily="34" charset="-122"/>
-                <a:cs typeface="SimHei" pitchFamily="34" charset="-120"/>
+                <a:latin typeface="Microsoft YaHei" pitchFamily="34" charset="0"/>
+                <a:ea typeface="Microsoft YaHei" pitchFamily="34" charset="-122"/>
+                <a:cs typeface="Microsoft YaHei" pitchFamily="34" charset="-120"/>
               </a:rPr>
               <a:t>联勤保障部队第九四〇医院</a:t>
             </a:r>
@@ -1618,9 +2709,9 @@
                 <a:solidFill>
                   <a:srgbClr val="33566B"/>
                 </a:solidFill>
-                <a:latin typeface="Microsoft YaHei" pitchFamily="34" charset="0"/>
-                <a:ea typeface="Microsoft YaHei" pitchFamily="34" charset="-122"/>
-                <a:cs typeface="Microsoft YaHei" pitchFamily="34" charset="-120"/>
+                <a:latin typeface="KaiTi" pitchFamily="34" charset="0"/>
+                <a:ea typeface="KaiTi" pitchFamily="34" charset="-122"/>
+                <a:cs typeface="KaiTi" pitchFamily="34" charset="-120"/>
               </a:rPr>
               <a:t>哈　小　琴</a:t>
             </a:r>
@@ -1735,9 +2826,9 @@
                 <a:solidFill>
                   <a:srgbClr val="2F3A55"/>
                 </a:solidFill>
-                <a:latin typeface="Source Han Sans CN" pitchFamily="34" charset="0"/>
-                <a:ea typeface="Source Han Sans CN" pitchFamily="34" charset="-122"/>
-                <a:cs typeface="Source Han Sans CN" pitchFamily="34" charset="-120"/>
+                <a:latin typeface="Microsoft YaHei" pitchFamily="34" charset="0"/>
+                <a:ea typeface="Microsoft YaHei" pitchFamily="34" charset="-122"/>
+                <a:cs typeface="Microsoft YaHei" pitchFamily="34" charset="-120"/>
               </a:rPr>
               <a:t>军队专业技术待遇五级选升答辩</a:t>
             </a:r>
@@ -1774,9 +2865,9 @@
                 <a:solidFill>
                   <a:srgbClr val="33566B"/>
                 </a:solidFill>
-                <a:latin typeface="KaiTi_GB2312" pitchFamily="34" charset="0"/>
-                <a:ea typeface="KaiTi_GB2312" pitchFamily="34" charset="-122"/>
-                <a:cs typeface="KaiTi_GB2312" pitchFamily="34" charset="-120"/>
+                <a:latin typeface="KaiTi" pitchFamily="34" charset="0"/>
+                <a:ea typeface="KaiTi" pitchFamily="34" charset="-122"/>
+                <a:cs typeface="KaiTi" pitchFamily="34" charset="-120"/>
               </a:rPr>
               <a:t>哈　小　琴</a:t>
             </a:r>
@@ -1813,9 +2904,9 @@
                 <a:solidFill>
                   <a:srgbClr val="3D5A6A"/>
                 </a:solidFill>
-                <a:latin typeface="Source Han Sans CN" pitchFamily="34" charset="0"/>
-                <a:ea typeface="Source Han Sans CN" pitchFamily="34" charset="-122"/>
-                <a:cs typeface="Source Han Sans CN" pitchFamily="34" charset="-120"/>
+                <a:latin typeface="Microsoft YaHei" pitchFamily="34" charset="0"/>
+                <a:ea typeface="Microsoft YaHei" pitchFamily="34" charset="-122"/>
+                <a:cs typeface="Microsoft YaHei" pitchFamily="34" charset="-120"/>
               </a:rPr>
               <a:t>联勤保障部队第九四〇医院</a:t>
             </a:r>
@@ -1930,9 +3021,9 @@
                 <a:solidFill>
                   <a:srgbClr val="33566B"/>
                 </a:solidFill>
-                <a:latin typeface="FangSong" pitchFamily="34" charset="0"/>
-                <a:ea typeface="FangSong" pitchFamily="34" charset="-122"/>
-                <a:cs typeface="FangSong" pitchFamily="34" charset="-120"/>
+                <a:latin typeface="KaiTi" pitchFamily="34" charset="0"/>
+                <a:ea typeface="KaiTi" pitchFamily="34" charset="-122"/>
+                <a:cs typeface="KaiTi" pitchFamily="34" charset="-120"/>
               </a:rPr>
               <a:t>哈　小　琴</a:t>
             </a:r>
@@ -1969,9 +3060,633 @@
                 <a:solidFill>
                   <a:srgbClr val="3D5A6A"/>
                 </a:solidFill>
-                <a:latin typeface="SimSun" pitchFamily="34" charset="0"/>
-                <a:ea typeface="SimSun" pitchFamily="34" charset="-122"/>
-                <a:cs typeface="SimSun" pitchFamily="34" charset="-120"/>
+                <a:latin typeface="Microsoft YaHei" pitchFamily="34" charset="0"/>
+                <a:ea typeface="Microsoft YaHei" pitchFamily="34" charset="-122"/>
+                <a:cs typeface="Microsoft YaHei" pitchFamily="34" charset="-120"/>
+              </a:rPr>
+              <a:t>联勤保障部队第九四〇医院</a:t>
+            </a:r>
+            <a:endParaRPr lang="en-US" sz="2800" dirty="0"/>
+          </a:p>
+        </p:txBody>
+      </p:sp>
+    </p:spTree>
+  </p:cSld>
+  <p:clrMapOvr>
+    <a:masterClrMapping/>
+  </p:clrMapOvr>
+</p:sld>
+</file>
+
+<file path=ppt/slides/slide6.xml><?xml version="1.0" encoding="utf-8"?>
+<p:sld xmlns:a="http://schemas.openxmlformats.org/drawingml/2006/main" xmlns:r="http://schemas.openxmlformats.org/officeDocument/2006/relationships" xmlns:p="http://schemas.openxmlformats.org/presentationml/2006/main">
+  <p:cSld name="Slide 6">
+    <p:bg>
+      <p:bgPr>
+        <a:blipFill dpi="0" rotWithShape="1">
+          <a:blip r:embed="rId1">
+            <a:lum/>
+          </a:blip>
+          <a:srcRect/>
+          <a:stretch>
+            <a:fillRect/>
+          </a:stretch>
+        </a:blipFill>
+        <a:effectLst/>
+      </p:bgPr>
+    </p:bg>
+    <p:spTree>
+      <p:nvGrpSpPr>
+        <p:cNvPr id="1" name=""/>
+        <p:cNvGrpSpPr/>
+        <p:nvPr/>
+      </p:nvGrpSpPr>
+      <p:grpSpPr>
+        <a:xfrm>
+          <a:off x="0" y="0"/>
+          <a:ext cx="0" cy="0"/>
+          <a:chOff x="0" y="0"/>
+          <a:chExt cx="0" cy="0"/>
+        </a:xfrm>
+      </p:grpSpPr>
+      <p:sp>
+        <p:nvSpPr>
+          <p:cNvPr id="2" name="标题"/>
+          <p:cNvSpPr txBox="1"/>
+          <p:nvPr/>
+        </p:nvSpPr>
+        <p:spPr>
+          <a:xfrm>
+            <a:off x="274320" y="1691640"/>
+            <a:ext cx="11640312" cy="914400"/>
+          </a:xfrm>
+          <a:prstGeom prst="rect">
+            <a:avLst/>
+          </a:prstGeom>
+          <a:noFill/>
+          <a:ln/>
+        </p:spPr>
+        <p:txBody>
+          <a:bodyPr wrap="square" lIns="0" tIns="0" rIns="0" bIns="0" rtlCol="0" anchor="ctr"/>
+          <a:lstStyle/>
+          <a:p>
+            <a:pPr algn="ctr" indent="0" marL="0">
+              <a:buNone/>
+            </a:pPr>
+            <a:r>
+              <a:rPr lang="en-US" sz="6000" b="1" dirty="0">
+                <a:solidFill>
+                  <a:srgbClr val="2F3A55"/>
+                </a:solidFill>
+                <a:latin typeface="Microsoft YaHei" pitchFamily="34" charset="0"/>
+                <a:ea typeface="Microsoft YaHei" pitchFamily="34" charset="-122"/>
+                <a:cs typeface="Microsoft YaHei" pitchFamily="34" charset="-120"/>
+              </a:rPr>
+              <a:t>军队专业技术待遇五级选升答辩</a:t>
+            </a:r>
+            <a:endParaRPr lang="en-US" sz="6000" dirty="0"/>
+          </a:p>
+        </p:txBody>
+      </p:sp>
+      <p:sp>
+        <p:nvSpPr>
+          <p:cNvPr id="3" name="姓名"/>
+          <p:cNvSpPr txBox="1"/>
+          <p:nvPr/>
+        </p:nvSpPr>
+        <p:spPr>
+          <a:xfrm>
+            <a:off x="3355848" y="3520440"/>
+            <a:ext cx="5486400" cy="822960"/>
+          </a:xfrm>
+          <a:prstGeom prst="rect">
+            <a:avLst/>
+          </a:prstGeom>
+          <a:noFill/>
+          <a:ln/>
+        </p:spPr>
+        <p:txBody>
+          <a:bodyPr wrap="square" lIns="0" tIns="0" rIns="0" bIns="0" rtlCol="0" anchor="ctr"/>
+          <a:lstStyle/>
+          <a:p>
+            <a:pPr algn="ctr" indent="0" marL="0">
+              <a:buNone/>
+            </a:pPr>
+            <a:r>
+              <a:rPr lang="en-US" sz="4400" dirty="0">
+                <a:solidFill>
+                  <a:srgbClr val="33566B"/>
+                </a:solidFill>
+                <a:latin typeface="KaiTi" pitchFamily="34" charset="0"/>
+                <a:ea typeface="KaiTi" pitchFamily="34" charset="-122"/>
+                <a:cs typeface="KaiTi" pitchFamily="34" charset="-120"/>
+              </a:rPr>
+              <a:t>哈　小　琴</a:t>
+            </a:r>
+            <a:endParaRPr lang="en-US" sz="4400" dirty="0"/>
+          </a:p>
+        </p:txBody>
+      </p:sp>
+      <p:sp>
+        <p:nvSpPr>
+          <p:cNvPr id="4" name="单位"/>
+          <p:cNvSpPr txBox="1"/>
+          <p:nvPr/>
+        </p:nvSpPr>
+        <p:spPr>
+          <a:xfrm>
+            <a:off x="2441448" y="4343400"/>
+            <a:ext cx="7315200" cy="731520"/>
+          </a:xfrm>
+          <a:prstGeom prst="rect">
+            <a:avLst/>
+          </a:prstGeom>
+          <a:noFill/>
+          <a:ln/>
+        </p:spPr>
+        <p:txBody>
+          <a:bodyPr wrap="square" lIns="0" tIns="0" rIns="0" bIns="0" rtlCol="0" anchor="ctr"/>
+          <a:lstStyle/>
+          <a:p>
+            <a:pPr algn="ctr" indent="0" marL="0">
+              <a:buNone/>
+            </a:pPr>
+            <a:r>
+              <a:rPr lang="en-US" sz="2800" dirty="0">
+                <a:solidFill>
+                  <a:srgbClr val="3D5A6A"/>
+                </a:solidFill>
+                <a:latin typeface="Microsoft YaHei" pitchFamily="34" charset="0"/>
+                <a:ea typeface="Microsoft YaHei" pitchFamily="34" charset="-122"/>
+                <a:cs typeface="Microsoft YaHei" pitchFamily="34" charset="-120"/>
+              </a:rPr>
+              <a:t>联勤保障部队第九四〇医院</a:t>
+            </a:r>
+            <a:endParaRPr lang="en-US" sz="2800" dirty="0"/>
+          </a:p>
+        </p:txBody>
+      </p:sp>
+    </p:spTree>
+  </p:cSld>
+  <p:clrMapOvr>
+    <a:masterClrMapping/>
+  </p:clrMapOvr>
+</p:sld>
+</file>
+
+<file path=ppt/slides/slide7.xml><?xml version="1.0" encoding="utf-8"?>
+<p:sld xmlns:a="http://schemas.openxmlformats.org/drawingml/2006/main" xmlns:r="http://schemas.openxmlformats.org/officeDocument/2006/relationships" xmlns:p="http://schemas.openxmlformats.org/presentationml/2006/main">
+  <p:cSld name="Slide 7">
+    <p:bg>
+      <p:bgPr>
+        <a:blipFill dpi="0" rotWithShape="1">
+          <a:blip r:embed="rId1">
+            <a:lum/>
+          </a:blip>
+          <a:srcRect/>
+          <a:stretch>
+            <a:fillRect/>
+          </a:stretch>
+        </a:blipFill>
+        <a:effectLst/>
+      </p:bgPr>
+    </p:bg>
+    <p:spTree>
+      <p:nvGrpSpPr>
+        <p:cNvPr id="1" name=""/>
+        <p:cNvGrpSpPr/>
+        <p:nvPr/>
+      </p:nvGrpSpPr>
+      <p:grpSpPr>
+        <a:xfrm>
+          <a:off x="0" y="0"/>
+          <a:ext cx="0" cy="0"/>
+          <a:chOff x="0" y="0"/>
+          <a:chExt cx="0" cy="0"/>
+        </a:xfrm>
+      </p:grpSpPr>
+      <p:sp>
+        <p:nvSpPr>
+          <p:cNvPr id="2" name="标题"/>
+          <p:cNvSpPr txBox="1"/>
+          <p:nvPr/>
+        </p:nvSpPr>
+        <p:spPr>
+          <a:xfrm>
+            <a:off x="274320" y="1691640"/>
+            <a:ext cx="11640312" cy="914400"/>
+          </a:xfrm>
+          <a:prstGeom prst="rect">
+            <a:avLst/>
+          </a:prstGeom>
+          <a:noFill/>
+          <a:ln/>
+        </p:spPr>
+        <p:txBody>
+          <a:bodyPr wrap="square" lIns="0" tIns="0" rIns="0" bIns="0" rtlCol="0" anchor="ctr"/>
+          <a:lstStyle/>
+          <a:p>
+            <a:pPr algn="ctr" indent="0" marL="0">
+              <a:buNone/>
+            </a:pPr>
+            <a:r>
+              <a:rPr lang="en-US" sz="6000" b="1" dirty="0">
+                <a:solidFill>
+                  <a:srgbClr val="2F3A55"/>
+                </a:solidFill>
+                <a:latin typeface="Microsoft YaHei" pitchFamily="34" charset="0"/>
+                <a:ea typeface="Microsoft YaHei" pitchFamily="34" charset="-122"/>
+                <a:cs typeface="Microsoft YaHei" pitchFamily="34" charset="-120"/>
+              </a:rPr>
+              <a:t>军队专业技术待遇五级选升答辩</a:t>
+            </a:r>
+            <a:endParaRPr lang="en-US" sz="6000" dirty="0"/>
+          </a:p>
+        </p:txBody>
+      </p:sp>
+      <p:sp>
+        <p:nvSpPr>
+          <p:cNvPr id="3" name="姓名"/>
+          <p:cNvSpPr txBox="1"/>
+          <p:nvPr/>
+        </p:nvSpPr>
+        <p:spPr>
+          <a:xfrm>
+            <a:off x="3355848" y="3520440"/>
+            <a:ext cx="5486400" cy="822960"/>
+          </a:xfrm>
+          <a:prstGeom prst="rect">
+            <a:avLst/>
+          </a:prstGeom>
+          <a:noFill/>
+          <a:ln/>
+        </p:spPr>
+        <p:txBody>
+          <a:bodyPr wrap="square" lIns="0" tIns="0" rIns="0" bIns="0" rtlCol="0" anchor="ctr"/>
+          <a:lstStyle/>
+          <a:p>
+            <a:pPr algn="ctr" indent="0" marL="0">
+              <a:buNone/>
+            </a:pPr>
+            <a:r>
+              <a:rPr lang="en-US" sz="4400" dirty="0">
+                <a:solidFill>
+                  <a:srgbClr val="33566B"/>
+                </a:solidFill>
+                <a:latin typeface="KaiTi" pitchFamily="34" charset="0"/>
+                <a:ea typeface="KaiTi" pitchFamily="34" charset="-122"/>
+                <a:cs typeface="KaiTi" pitchFamily="34" charset="-120"/>
+              </a:rPr>
+              <a:t>哈　小　琴</a:t>
+            </a:r>
+            <a:endParaRPr lang="en-US" sz="4400" dirty="0"/>
+          </a:p>
+        </p:txBody>
+      </p:sp>
+      <p:sp>
+        <p:nvSpPr>
+          <p:cNvPr id="4" name="单位"/>
+          <p:cNvSpPr txBox="1"/>
+          <p:nvPr/>
+        </p:nvSpPr>
+        <p:spPr>
+          <a:xfrm>
+            <a:off x="2441448" y="4343400"/>
+            <a:ext cx="7315200" cy="731520"/>
+          </a:xfrm>
+          <a:prstGeom prst="rect">
+            <a:avLst/>
+          </a:prstGeom>
+          <a:noFill/>
+          <a:ln/>
+        </p:spPr>
+        <p:txBody>
+          <a:bodyPr wrap="square" lIns="0" tIns="0" rIns="0" bIns="0" rtlCol="0" anchor="ctr"/>
+          <a:lstStyle/>
+          <a:p>
+            <a:pPr algn="ctr" indent="0" marL="0">
+              <a:buNone/>
+            </a:pPr>
+            <a:r>
+              <a:rPr lang="en-US" sz="2800" dirty="0">
+                <a:solidFill>
+                  <a:srgbClr val="3D5A6A"/>
+                </a:solidFill>
+                <a:latin typeface="Microsoft YaHei" pitchFamily="34" charset="0"/>
+                <a:ea typeface="Microsoft YaHei" pitchFamily="34" charset="-122"/>
+                <a:cs typeface="Microsoft YaHei" pitchFamily="34" charset="-120"/>
+              </a:rPr>
+              <a:t>联勤保障部队第九四〇医院</a:t>
+            </a:r>
+            <a:endParaRPr lang="en-US" sz="2800" dirty="0"/>
+          </a:p>
+        </p:txBody>
+      </p:sp>
+    </p:spTree>
+  </p:cSld>
+  <p:clrMapOvr>
+    <a:masterClrMapping/>
+  </p:clrMapOvr>
+</p:sld>
+</file>
+
+<file path=ppt/slides/slide8.xml><?xml version="1.0" encoding="utf-8"?>
+<p:sld xmlns:a="http://schemas.openxmlformats.org/drawingml/2006/main" xmlns:r="http://schemas.openxmlformats.org/officeDocument/2006/relationships" xmlns:p="http://schemas.openxmlformats.org/presentationml/2006/main">
+  <p:cSld name="Slide 8">
+    <p:bg>
+      <p:bgPr>
+        <a:blipFill dpi="0" rotWithShape="1">
+          <a:blip r:embed="rId1">
+            <a:lum/>
+          </a:blip>
+          <a:srcRect/>
+          <a:stretch>
+            <a:fillRect/>
+          </a:stretch>
+        </a:blipFill>
+        <a:effectLst/>
+      </p:bgPr>
+    </p:bg>
+    <p:spTree>
+      <p:nvGrpSpPr>
+        <p:cNvPr id="1" name=""/>
+        <p:cNvGrpSpPr/>
+        <p:nvPr/>
+      </p:nvGrpSpPr>
+      <p:grpSpPr>
+        <a:xfrm>
+          <a:off x="0" y="0"/>
+          <a:ext cx="0" cy="0"/>
+          <a:chOff x="0" y="0"/>
+          <a:chExt cx="0" cy="0"/>
+        </a:xfrm>
+      </p:grpSpPr>
+      <p:sp>
+        <p:nvSpPr>
+          <p:cNvPr id="2" name="标题"/>
+          <p:cNvSpPr txBox="1"/>
+          <p:nvPr/>
+        </p:nvSpPr>
+        <p:spPr>
+          <a:xfrm>
+            <a:off x="274320" y="1691640"/>
+            <a:ext cx="11640312" cy="914400"/>
+          </a:xfrm>
+          <a:prstGeom prst="rect">
+            <a:avLst/>
+          </a:prstGeom>
+          <a:noFill/>
+          <a:ln/>
+        </p:spPr>
+        <p:txBody>
+          <a:bodyPr wrap="square" lIns="0" tIns="0" rIns="0" bIns="0" rtlCol="0" anchor="ctr"/>
+          <a:lstStyle/>
+          <a:p>
+            <a:pPr algn="ctr" indent="0" marL="0">
+              <a:buNone/>
+            </a:pPr>
+            <a:r>
+              <a:rPr lang="en-US" sz="6000" b="1" dirty="0">
+                <a:solidFill>
+                  <a:srgbClr val="2F3A55"/>
+                </a:solidFill>
+                <a:latin typeface="Microsoft YaHei" pitchFamily="34" charset="0"/>
+                <a:ea typeface="Microsoft YaHei" pitchFamily="34" charset="-122"/>
+                <a:cs typeface="Microsoft YaHei" pitchFamily="34" charset="-120"/>
+              </a:rPr>
+              <a:t>军队专业技术待遇五级选升答辩</a:t>
+            </a:r>
+            <a:endParaRPr lang="en-US" sz="6000" dirty="0"/>
+          </a:p>
+        </p:txBody>
+      </p:sp>
+      <p:sp>
+        <p:nvSpPr>
+          <p:cNvPr id="3" name="姓名"/>
+          <p:cNvSpPr txBox="1"/>
+          <p:nvPr/>
+        </p:nvSpPr>
+        <p:spPr>
+          <a:xfrm>
+            <a:off x="3355848" y="3520440"/>
+            <a:ext cx="5486400" cy="822960"/>
+          </a:xfrm>
+          <a:prstGeom prst="rect">
+            <a:avLst/>
+          </a:prstGeom>
+          <a:noFill/>
+          <a:ln/>
+        </p:spPr>
+        <p:txBody>
+          <a:bodyPr wrap="square" lIns="0" tIns="0" rIns="0" bIns="0" rtlCol="0" anchor="ctr"/>
+          <a:lstStyle/>
+          <a:p>
+            <a:pPr algn="ctr" indent="0" marL="0">
+              <a:buNone/>
+            </a:pPr>
+            <a:r>
+              <a:rPr lang="en-US" sz="4400" dirty="0">
+                <a:solidFill>
+                  <a:srgbClr val="33566B"/>
+                </a:solidFill>
+                <a:latin typeface="KaiTi" pitchFamily="34" charset="0"/>
+                <a:ea typeface="KaiTi" pitchFamily="34" charset="-122"/>
+                <a:cs typeface="KaiTi" pitchFamily="34" charset="-120"/>
+              </a:rPr>
+              <a:t>哈　小　琴</a:t>
+            </a:r>
+            <a:endParaRPr lang="en-US" sz="4400" dirty="0"/>
+          </a:p>
+        </p:txBody>
+      </p:sp>
+      <p:sp>
+        <p:nvSpPr>
+          <p:cNvPr id="4" name="单位"/>
+          <p:cNvSpPr txBox="1"/>
+          <p:nvPr/>
+        </p:nvSpPr>
+        <p:spPr>
+          <a:xfrm>
+            <a:off x="2441448" y="4343400"/>
+            <a:ext cx="7315200" cy="731520"/>
+          </a:xfrm>
+          <a:prstGeom prst="rect">
+            <a:avLst/>
+          </a:prstGeom>
+          <a:noFill/>
+          <a:ln/>
+        </p:spPr>
+        <p:txBody>
+          <a:bodyPr wrap="square" lIns="0" tIns="0" rIns="0" bIns="0" rtlCol="0" anchor="ctr"/>
+          <a:lstStyle/>
+          <a:p>
+            <a:pPr algn="ctr" indent="0" marL="0">
+              <a:buNone/>
+            </a:pPr>
+            <a:r>
+              <a:rPr lang="en-US" sz="2800" dirty="0">
+                <a:solidFill>
+                  <a:srgbClr val="3D5A6A"/>
+                </a:solidFill>
+                <a:latin typeface="Microsoft YaHei" pitchFamily="34" charset="0"/>
+                <a:ea typeface="Microsoft YaHei" pitchFamily="34" charset="-122"/>
+                <a:cs typeface="Microsoft YaHei" pitchFamily="34" charset="-120"/>
+              </a:rPr>
+              <a:t>联勤保障部队第九四〇医院</a:t>
+            </a:r>
+            <a:endParaRPr lang="en-US" sz="2800" dirty="0"/>
+          </a:p>
+        </p:txBody>
+      </p:sp>
+    </p:spTree>
+  </p:cSld>
+  <p:clrMapOvr>
+    <a:masterClrMapping/>
+  </p:clrMapOvr>
+</p:sld>
+</file>
+
+<file path=ppt/slides/slide9.xml><?xml version="1.0" encoding="utf-8"?>
+<p:sld xmlns:a="http://schemas.openxmlformats.org/drawingml/2006/main" xmlns:r="http://schemas.openxmlformats.org/officeDocument/2006/relationships" xmlns:p="http://schemas.openxmlformats.org/presentationml/2006/main">
+  <p:cSld name="Slide 9">
+    <p:bg>
+      <p:bgPr>
+        <a:blipFill dpi="0" rotWithShape="1">
+          <a:blip r:embed="rId1">
+            <a:lum/>
+          </a:blip>
+          <a:srcRect/>
+          <a:stretch>
+            <a:fillRect/>
+          </a:stretch>
+        </a:blipFill>
+        <a:effectLst/>
+      </p:bgPr>
+    </p:bg>
+    <p:spTree>
+      <p:nvGrpSpPr>
+        <p:cNvPr id="1" name=""/>
+        <p:cNvGrpSpPr/>
+        <p:nvPr/>
+      </p:nvGrpSpPr>
+      <p:grpSpPr>
+        <a:xfrm>
+          <a:off x="0" y="0"/>
+          <a:ext cx="0" cy="0"/>
+          <a:chOff x="0" y="0"/>
+          <a:chExt cx="0" cy="0"/>
+        </a:xfrm>
+      </p:grpSpPr>
+      <p:sp>
+        <p:nvSpPr>
+          <p:cNvPr id="2" name="标题"/>
+          <p:cNvSpPr txBox="1"/>
+          <p:nvPr/>
+        </p:nvSpPr>
+        <p:spPr>
+          <a:xfrm>
+            <a:off x="274320" y="1691640"/>
+            <a:ext cx="11640312" cy="914400"/>
+          </a:xfrm>
+          <a:prstGeom prst="rect">
+            <a:avLst/>
+          </a:prstGeom>
+          <a:noFill/>
+          <a:ln/>
+        </p:spPr>
+        <p:txBody>
+          <a:bodyPr wrap="square" lIns="0" tIns="0" rIns="0" bIns="0" rtlCol="0" anchor="ctr"/>
+          <a:lstStyle/>
+          <a:p>
+            <a:pPr algn="ctr" indent="0" marL="0">
+              <a:buNone/>
+            </a:pPr>
+            <a:r>
+              <a:rPr lang="en-US" sz="6000" b="1" dirty="0">
+                <a:solidFill>
+                  <a:srgbClr val="2F3A55"/>
+                </a:solidFill>
+                <a:latin typeface="SimHei" pitchFamily="34" charset="0"/>
+                <a:ea typeface="SimHei" pitchFamily="34" charset="-122"/>
+                <a:cs typeface="SimHei" pitchFamily="34" charset="-120"/>
+              </a:rPr>
+              <a:t>军队专业技术待遇五级选升答辩</a:t>
+            </a:r>
+            <a:endParaRPr lang="en-US" sz="6000" dirty="0"/>
+          </a:p>
+        </p:txBody>
+      </p:sp>
+      <p:sp>
+        <p:nvSpPr>
+          <p:cNvPr id="3" name="姓名"/>
+          <p:cNvSpPr txBox="1"/>
+          <p:nvPr/>
+        </p:nvSpPr>
+        <p:spPr>
+          <a:xfrm>
+            <a:off x="3355848" y="3520440"/>
+            <a:ext cx="5486400" cy="822960"/>
+          </a:xfrm>
+          <a:prstGeom prst="rect">
+            <a:avLst/>
+          </a:prstGeom>
+          <a:noFill/>
+          <a:ln/>
+        </p:spPr>
+        <p:txBody>
+          <a:bodyPr wrap="square" lIns="0" tIns="0" rIns="0" bIns="0" rtlCol="0" anchor="ctr"/>
+          <a:lstStyle/>
+          <a:p>
+            <a:pPr algn="ctr" indent="0" marL="0">
+              <a:buNone/>
+            </a:pPr>
+            <a:r>
+              <a:rPr lang="en-US" sz="4400" dirty="0">
+                <a:solidFill>
+                  <a:srgbClr val="33566B"/>
+                </a:solidFill>
+                <a:latin typeface="STKaiti" pitchFamily="34" charset="0"/>
+                <a:ea typeface="STKaiti" pitchFamily="34" charset="-122"/>
+                <a:cs typeface="STKaiti" pitchFamily="34" charset="-120"/>
+              </a:rPr>
+              <a:t>哈　小　琴</a:t>
+            </a:r>
+            <a:endParaRPr lang="en-US" sz="4400" dirty="0"/>
+          </a:p>
+        </p:txBody>
+      </p:sp>
+      <p:sp>
+        <p:nvSpPr>
+          <p:cNvPr id="4" name="单位"/>
+          <p:cNvSpPr txBox="1"/>
+          <p:nvPr/>
+        </p:nvSpPr>
+        <p:spPr>
+          <a:xfrm>
+            <a:off x="2441448" y="4343400"/>
+            <a:ext cx="7315200" cy="731520"/>
+          </a:xfrm>
+          <a:prstGeom prst="rect">
+            <a:avLst/>
+          </a:prstGeom>
+          <a:noFill/>
+          <a:ln/>
+        </p:spPr>
+        <p:txBody>
+          <a:bodyPr wrap="square" lIns="0" tIns="0" rIns="0" bIns="0" rtlCol="0" anchor="ctr"/>
+          <a:lstStyle/>
+          <a:p>
+            <a:pPr algn="ctr" indent="0" marL="0">
+              <a:buNone/>
+            </a:pPr>
+            <a:r>
+              <a:rPr lang="en-US" sz="2800" dirty="0">
+                <a:solidFill>
+                  <a:srgbClr val="3D5A6A"/>
+                </a:solidFill>
+                <a:latin typeface="SimHei" pitchFamily="34" charset="0"/>
+                <a:ea typeface="SimHei" pitchFamily="34" charset="-122"/>
+                <a:cs typeface="SimHei" pitchFamily="34" charset="-120"/>
               </a:rPr>
               <a:t>联勤保障部队第九四〇医院</a:t>
             </a:r>

</xml_diff>